<commit_message>
add new and update ppts
</commit_message>
<xml_diff>
--- a/Hanamo.pptx
+++ b/Hanamo.pptx
@@ -301,7 +301,7 @@
           <a:p>
             <a:fld id="{1C488704-7058-4526-95CD-2A163221AB6F}" type="datetimeFigureOut">
               <a:rPr lang="en-US" smtClean="0"/>
-              <a:t>10/31/2025</a:t>
+              <a:t>4/17/2026</a:t>
             </a:fld>
             <a:endParaRPr lang="en-US"/>
           </a:p>
@@ -471,7 +471,7 @@
           <a:p>
             <a:fld id="{1C488704-7058-4526-95CD-2A163221AB6F}" type="datetimeFigureOut">
               <a:rPr lang="en-US" smtClean="0"/>
-              <a:t>10/31/2025</a:t>
+              <a:t>4/17/2026</a:t>
             </a:fld>
             <a:endParaRPr lang="en-US"/>
           </a:p>
@@ -651,7 +651,7 @@
           <a:p>
             <a:fld id="{1C488704-7058-4526-95CD-2A163221AB6F}" type="datetimeFigureOut">
               <a:rPr lang="en-US" smtClean="0"/>
-              <a:t>10/31/2025</a:t>
+              <a:t>4/17/2026</a:t>
             </a:fld>
             <a:endParaRPr lang="en-US"/>
           </a:p>
@@ -821,7 +821,7 @@
           <a:p>
             <a:fld id="{1C488704-7058-4526-95CD-2A163221AB6F}" type="datetimeFigureOut">
               <a:rPr lang="en-US" smtClean="0"/>
-              <a:t>10/31/2025</a:t>
+              <a:t>4/17/2026</a:t>
             </a:fld>
             <a:endParaRPr lang="en-US"/>
           </a:p>
@@ -1067,7 +1067,7 @@
           <a:p>
             <a:fld id="{1C488704-7058-4526-95CD-2A163221AB6F}" type="datetimeFigureOut">
               <a:rPr lang="en-US" smtClean="0"/>
-              <a:t>10/31/2025</a:t>
+              <a:t>4/17/2026</a:t>
             </a:fld>
             <a:endParaRPr lang="en-US"/>
           </a:p>
@@ -1355,7 +1355,7 @@
           <a:p>
             <a:fld id="{1C488704-7058-4526-95CD-2A163221AB6F}" type="datetimeFigureOut">
               <a:rPr lang="en-US" smtClean="0"/>
-              <a:t>10/31/2025</a:t>
+              <a:t>4/17/2026</a:t>
             </a:fld>
             <a:endParaRPr lang="en-US"/>
           </a:p>
@@ -1777,7 +1777,7 @@
           <a:p>
             <a:fld id="{1C488704-7058-4526-95CD-2A163221AB6F}" type="datetimeFigureOut">
               <a:rPr lang="en-US" smtClean="0"/>
-              <a:t>10/31/2025</a:t>
+              <a:t>4/17/2026</a:t>
             </a:fld>
             <a:endParaRPr lang="en-US"/>
           </a:p>
@@ -1895,7 +1895,7 @@
           <a:p>
             <a:fld id="{1C488704-7058-4526-95CD-2A163221AB6F}" type="datetimeFigureOut">
               <a:rPr lang="en-US" smtClean="0"/>
-              <a:t>10/31/2025</a:t>
+              <a:t>4/17/2026</a:t>
             </a:fld>
             <a:endParaRPr lang="en-US"/>
           </a:p>
@@ -1990,7 +1990,7 @@
           <a:p>
             <a:fld id="{1C488704-7058-4526-95CD-2A163221AB6F}" type="datetimeFigureOut">
               <a:rPr lang="en-US" smtClean="0"/>
-              <a:t>10/31/2025</a:t>
+              <a:t>4/17/2026</a:t>
             </a:fld>
             <a:endParaRPr lang="en-US"/>
           </a:p>
@@ -2267,7 +2267,7 @@
           <a:p>
             <a:fld id="{1C488704-7058-4526-95CD-2A163221AB6F}" type="datetimeFigureOut">
               <a:rPr lang="en-US" smtClean="0"/>
-              <a:t>10/31/2025</a:t>
+              <a:t>4/17/2026</a:t>
             </a:fld>
             <a:endParaRPr lang="en-US"/>
           </a:p>
@@ -2524,7 +2524,7 @@
           <a:p>
             <a:fld id="{1C488704-7058-4526-95CD-2A163221AB6F}" type="datetimeFigureOut">
               <a:rPr lang="en-US" smtClean="0"/>
-              <a:t>10/31/2025</a:t>
+              <a:t>4/17/2026</a:t>
             </a:fld>
             <a:endParaRPr lang="en-US"/>
           </a:p>
@@ -2740,7 +2740,7 @@
           <a:p>
             <a:fld id="{1C488704-7058-4526-95CD-2A163221AB6F}" type="datetimeFigureOut">
               <a:rPr lang="en-US" smtClean="0"/>
-              <a:t>10/31/2025</a:t>
+              <a:t>4/17/2026</a:t>
             </a:fld>
             <a:endParaRPr lang="en-US"/>
           </a:p>
@@ -3150,6 +3150,23 @@
           <a:lstStyle/>
           <a:p>
             <a:r>
+              <a:rPr lang="zh-CN" altLang="en-US" sz="7200" b="1" i="1" dirty="0">
+                <a:solidFill>
+                  <a:srgbClr val="000066"/>
+                </a:solidFill>
+                <a:effectLst>
+                  <a:outerShdw blurRad="38100" dist="38100" dir="2700000" algn="tl">
+                    <a:srgbClr val="000000">
+                      <a:alpha val="43137"/>
+                    </a:srgbClr>
+                  </a:outerShdw>
+                </a:effectLst>
+                <a:latin typeface="微軟正黑體" pitchFamily="34" charset="-120"/>
+                <a:ea typeface="微軟正黑體" pitchFamily="34" charset="-120"/>
+              </a:rPr>
+              <a:t>花 </a:t>
+            </a:r>
+            <a:r>
               <a:rPr lang="en-US" altLang="zh-TW" sz="7200" b="1" i="1" dirty="0" err="1">
                 <a:solidFill>
                   <a:srgbClr val="000066"/>
@@ -3165,39 +3182,6 @@
                 <a:ea typeface="微軟正黑體" pitchFamily="34" charset="-120"/>
               </a:rPr>
               <a:t>Hanamo</a:t>
-            </a:r>
-            <a:br>
-              <a:rPr lang="en-US" altLang="zh-TW" sz="7200" b="1" i="1" dirty="0">
-                <a:solidFill>
-                  <a:srgbClr val="000066"/>
-                </a:solidFill>
-                <a:effectLst>
-                  <a:outerShdw blurRad="38100" dist="38100" dir="2700000" algn="tl">
-                    <a:srgbClr val="000000">
-                      <a:alpha val="43137"/>
-                    </a:srgbClr>
-                  </a:outerShdw>
-                </a:effectLst>
-                <a:latin typeface="微軟正黑體" pitchFamily="34" charset="-120"/>
-                <a:ea typeface="微軟正黑體" pitchFamily="34" charset="-120"/>
-              </a:rPr>
-            </a:br>
-            <a:r>
-              <a:rPr lang="en-US" altLang="zh-TW" sz="5400" b="1" i="1" dirty="0">
-                <a:solidFill>
-                  <a:srgbClr val="000066"/>
-                </a:solidFill>
-                <a:effectLst>
-                  <a:outerShdw blurRad="38100" dist="38100" dir="2700000" algn="tl">
-                    <a:srgbClr val="000000">
-                      <a:alpha val="43137"/>
-                    </a:srgbClr>
-                  </a:outerShdw>
-                </a:effectLst>
-                <a:latin typeface="微軟正黑體" pitchFamily="34" charset="-120"/>
-                <a:ea typeface="微軟正黑體" pitchFamily="34" charset="-120"/>
-              </a:rPr>
-              <a:t>Even in Flowers</a:t>
             </a:r>
             <a:endParaRPr lang="zh-TW" altLang="en-US" sz="7200" b="1" i="1" dirty="0">
               <a:solidFill>
@@ -3291,7 +3275,7 @@
                 <a:latin typeface="微軟正黑體" pitchFamily="34" charset="-120"/>
                 <a:ea typeface="微軟正黑體" pitchFamily="34" charset="-120"/>
               </a:rPr>
-              <a:t>生命泉  湧流不停歇</a:t>
+              <a:t>生命泉   湧流不停歇</a:t>
             </a:r>
           </a:p>
           <a:p>
@@ -3365,7 +3349,17 @@
                 <a:latin typeface="Microsoft JhengHei" panose="020B0604030504040204" pitchFamily="34" charset="-120"/>
                 <a:ea typeface="Microsoft JhengHei" panose="020B0604030504040204" pitchFamily="34" charset="-120"/>
               </a:rPr>
-              <a:t>正歌</a:t>
+              <a:t>正歌 </a:t>
+            </a:r>
+            <a:r>
+              <a:rPr lang="en-US" altLang="zh-CN" sz="3200" b="1" dirty="0">
+                <a:solidFill>
+                  <a:srgbClr val="000066"/>
+                </a:solidFill>
+                <a:latin typeface="Microsoft JhengHei" panose="020B0604030504040204" pitchFamily="34" charset="-120"/>
+                <a:ea typeface="Microsoft JhengHei" panose="020B0604030504040204" pitchFamily="34" charset="-120"/>
+              </a:rPr>
+              <a:t>1</a:t>
             </a:r>
             <a:r>
               <a:rPr lang="en-US" sz="3200" b="1" dirty="0">
@@ -3461,7 +3455,7 @@
                 <a:latin typeface="微軟正黑體" pitchFamily="34" charset="-120"/>
                 <a:ea typeface="微軟正黑體" pitchFamily="34" charset="-120"/>
               </a:rPr>
-              <a:t>到那日  碩果結滿園 </a:t>
+              <a:t>到那日   碩果結滿園 </a:t>
             </a:r>
           </a:p>
           <a:p>
@@ -3535,7 +3529,17 @@
                 <a:latin typeface="Microsoft JhengHei" panose="020B0604030504040204" pitchFamily="34" charset="-120"/>
                 <a:ea typeface="Microsoft JhengHei" panose="020B0604030504040204" pitchFamily="34" charset="-120"/>
               </a:rPr>
-              <a:t>正歌</a:t>
+              <a:t>正歌 </a:t>
+            </a:r>
+            <a:r>
+              <a:rPr lang="en-US" altLang="zh-CN" sz="3200" b="1" dirty="0">
+                <a:solidFill>
+                  <a:srgbClr val="000066"/>
+                </a:solidFill>
+                <a:latin typeface="Microsoft JhengHei" panose="020B0604030504040204" pitchFamily="34" charset="-120"/>
+                <a:ea typeface="Microsoft JhengHei" panose="020B0604030504040204" pitchFamily="34" charset="-120"/>
+              </a:rPr>
+              <a:t>1</a:t>
             </a:r>
             <a:r>
               <a:rPr lang="en-US" sz="3200" b="1" dirty="0">
@@ -3631,7 +3635,7 @@
                 <a:latin typeface="微軟正黑體" pitchFamily="34" charset="-120"/>
                 <a:ea typeface="微軟正黑體" pitchFamily="34" charset="-120"/>
               </a:rPr>
-              <a:t>抬頭望  天堂門打開 </a:t>
+              <a:t>抬頭望   天堂門打開 </a:t>
             </a:r>
           </a:p>
           <a:p>
@@ -3705,7 +3709,17 @@
                 <a:latin typeface="Microsoft JhengHei" panose="020B0604030504040204" pitchFamily="34" charset="-120"/>
                 <a:ea typeface="Microsoft JhengHei" panose="020B0604030504040204" pitchFamily="34" charset="-120"/>
               </a:rPr>
-              <a:t>正歌</a:t>
+              <a:t>正歌 </a:t>
+            </a:r>
+            <a:r>
+              <a:rPr lang="en-US" altLang="zh-CN" sz="3200" b="1" dirty="0">
+                <a:solidFill>
+                  <a:srgbClr val="000066"/>
+                </a:solidFill>
+                <a:latin typeface="Microsoft JhengHei" panose="020B0604030504040204" pitchFamily="34" charset="-120"/>
+                <a:ea typeface="Microsoft JhengHei" panose="020B0604030504040204" pitchFamily="34" charset="-120"/>
+              </a:rPr>
+              <a:t>2</a:t>
             </a:r>
             <a:r>
               <a:rPr lang="en-US" sz="3200" b="1" dirty="0">
@@ -3801,7 +3815,7 @@
                 <a:latin typeface="微軟正黑體" pitchFamily="34" charset="-120"/>
                 <a:ea typeface="微軟正黑體" pitchFamily="34" charset="-120"/>
               </a:rPr>
-              <a:t>百花開  芬芳遍滿地 </a:t>
+              <a:t>百花開   芬芳遍滿地 </a:t>
             </a:r>
           </a:p>
           <a:p>
@@ -3875,7 +3889,17 @@
                 <a:latin typeface="Microsoft JhengHei" panose="020B0604030504040204" pitchFamily="34" charset="-120"/>
                 <a:ea typeface="Microsoft JhengHei" panose="020B0604030504040204" pitchFamily="34" charset="-120"/>
               </a:rPr>
-              <a:t>正歌</a:t>
+              <a:t>正歌 </a:t>
+            </a:r>
+            <a:r>
+              <a:rPr lang="en-US" altLang="zh-CN" sz="3200" b="1" dirty="0">
+                <a:solidFill>
+                  <a:srgbClr val="000066"/>
+                </a:solidFill>
+                <a:latin typeface="Microsoft JhengHei" panose="020B0604030504040204" pitchFamily="34" charset="-120"/>
+                <a:ea typeface="Microsoft JhengHei" panose="020B0604030504040204" pitchFamily="34" charset="-120"/>
+              </a:rPr>
+              <a:t>2</a:t>
             </a:r>
             <a:r>
               <a:rPr lang="en-US" sz="3200" b="1" dirty="0">
@@ -3971,7 +3995,7 @@
                 <a:latin typeface="微軟正黑體" pitchFamily="34" charset="-120"/>
                 <a:ea typeface="微軟正黑體" pitchFamily="34" charset="-120"/>
               </a:rPr>
-              <a:t>花清香  雲徜徉</a:t>
+              <a:t>花清香   雲徜徉</a:t>
             </a:r>
             <a:endParaRPr lang="en-US" altLang="zh-TW" sz="6400" b="1" dirty="0">
               <a:solidFill>
@@ -4328,7 +4352,7 @@
                 <a:latin typeface="微軟正黑體" pitchFamily="34" charset="-120"/>
                 <a:ea typeface="微軟正黑體" pitchFamily="34" charset="-120"/>
               </a:rPr>
-              <a:t>聲響徹 心翱翔</a:t>
+              <a:t>聲響徹  心翱翔</a:t>
             </a:r>
             <a:endParaRPr lang="en-US" altLang="zh-TW" sz="6400" b="1" dirty="0">
               <a:solidFill>

</xml_diff>